<commit_message>
Keep Region and City lines on Dashboard covers
- Complete an empty or unavailable per-CDR Region/City catalogue with the
  Dashboard's own filter values in the viewer, export dialog and PPT cover
- Add regression test and changelog entry

Co-Authored-By: Claude Opus 5.5 <noreply@anthropic.com>
</commit_message>
<xml_diff>
--- a/assets/ppt-templates/Template_CDR_analysis.pptx
+++ b/assets/ppt-templates/Template_CDR_analysis.pptx
@@ -213,7 +213,7 @@
           <a:p>
             <a:fld id="{8CE9DB08-0204-FF45-B45D-D96F9C704D75}" type="datetimeFigureOut">
               <a:rPr lang="es-ES" smtClean="0"/>
-              <a:t>15/9/26</a:t>
+              <a:t>27/9/26</a:t>
             </a:fld>
             <a:endParaRPr lang="es-ES"/>
           </a:p>
@@ -390,7 +390,7 @@
           <a:p>
             <a:fld id="{56B6DF60-6159-4558-8D07-00E18A77A544}" type="datetimeFigureOut">
               <a:rPr lang="en-US" smtClean="0"/>
-              <a:t>9/15/26</a:t>
+              <a:t>9/27/26</a:t>
             </a:fld>
             <a:endParaRPr lang="en-US"/>
           </a:p>
@@ -717,7 +717,7 @@
         <p:spPr>
           <a:xfrm>
             <a:off x="479424" y="2121418"/>
-            <a:ext cx="10056053" cy="2048048"/>
+            <a:ext cx="9766799" cy="2048048"/>
           </a:xfrm>
         </p:spPr>
         <p:txBody>
@@ -756,7 +756,7 @@
         <p:spPr>
           <a:xfrm>
             <a:off x="479424" y="4329789"/>
-            <a:ext cx="10056052" cy="843526"/>
+            <a:ext cx="9766799" cy="843526"/>
           </a:xfrm>
           <a:prstGeom prst="rect">
             <a:avLst/>
@@ -24565,7 +24565,7 @@
           <a:p>
             <a:fld id="{EAB07A04-4D14-4FB4-ABC3-4FF79A2401A4}" type="datetimeFigureOut">
               <a:rPr lang="en-US" smtClean="0"/>
-              <a:t>9/15/26</a:t>
+              <a:t>9/27/26</a:t>
             </a:fld>
             <a:endParaRPr lang="en-US"/>
           </a:p>
@@ -24785,7 +24785,7 @@
           <a:p>
             <a:fld id="{E79BC93B-D740-4A24-9033-971140705A34}" type="datetimeFigureOut">
               <a:rPr lang="en-US" smtClean="0"/>
-              <a:t>9/15/26</a:t>
+              <a:t>9/27/26</a:t>
             </a:fld>
             <a:endParaRPr lang="en-US"/>
           </a:p>
@@ -28648,18 +28648,22 @@
 </file>
 
 <file path=customXml/item10.xml><?xml version="1.0" encoding="utf-8"?>
-<TemplafySlideTemplateConfiguration><![CDATA[{"documentContentValidatorConfiguration":{"enableDocumentContentValidator":false,"documentContentValidatorVersion":0},"elementsMetadata":[],"slideId":"637661701761217959","enableDocumentContentUpdater":true,"version":"1.9"}]]></TemplafySlideTemplateConfiguration>
+<p:properties xmlns:p="http://schemas.microsoft.com/office/2006/metadata/properties" xmlns:xsi="http://www.w3.org/2001/XMLSchema-instance" xmlns:pc="http://schemas.microsoft.com/office/infopath/2007/PartnerControls">
+  <documentManagement>
+    <TaxCatchAll xmlns="bcef248d-09fe-4034-af42-7800fb0b4c07" xsi:nil="true"/>
+    <lcf76f155ced4ddcb4097134ff3c332f xmlns="77fde15d-2397-485e-b73a-86b486d76ed9">
+      <Terms xmlns="http://schemas.microsoft.com/office/infopath/2007/PartnerControls"/>
+    </lcf76f155ced4ddcb4097134ff3c332f>
+    <_Flow_SignoffStatus xmlns="77fde15d-2397-485e-b73a-86b486d76ed9" xsi:nil="true"/>
+  </documentManagement>
+</p:properties>
 </file>
 
 <file path=customXml/item11.xml><?xml version="1.0" encoding="utf-8"?>
-<TemplafySlideTemplateConfiguration><![CDATA[{"documentContentValidatorConfiguration":{"enableDocumentContentValidator":false,"documentContentValidatorVersion":0},"elementsMetadata":[],"slideId":"637661701761217959","enableDocumentContentUpdater":true,"version":"1.9"}]]></TemplafySlideTemplateConfiguration>
+<TemplafySlideFormConfiguration><![CDATA[{"formFields":[],"formDataEntries":[]}]]></TemplafySlideFormConfiguration>
 </file>
 
 <file path=customXml/item12.xml><?xml version="1.0" encoding="utf-8"?>
-<TemplafySlideFormConfiguration><![CDATA[{"formFields":[],"formDataEntries":[]}]]></TemplafySlideFormConfiguration>
-</file>
-
-<file path=customXml/item13.xml><?xml version="1.0" encoding="utf-8"?>
 <ct:contentTypeSchema xmlns:ct="http://schemas.microsoft.com/office/2006/metadata/contentType" xmlns:ma="http://schemas.microsoft.com/office/2006/metadata/properties/metaAttributes" ct:_="" ma:_="" ma:contentTypeName="Documento" ma:contentTypeID="0x01010093E8D57ECA48EA49A8079FF7BA4D8434" ma:contentTypeVersion="14" ma:contentTypeDescription="Crear nuevo documento." ma:contentTypeScope="" ma:versionID="63c20a81180abc05dcc77631795f2f6d">
   <xsd:schema xmlns:xsd="http://www.w3.org/2001/XMLSchema" xmlns:xs="http://www.w3.org/2001/XMLSchema" xmlns:p="http://schemas.microsoft.com/office/2006/metadata/properties" xmlns:ns2="77fde15d-2397-485e-b73a-86b486d76ed9" xmlns:ns3="bcef248d-09fe-4034-af42-7800fb0b4c07" targetNamespace="http://schemas.microsoft.com/office/2006/metadata/properties" ma:root="true" ma:fieldsID="c568fcd95f5d4d3e7cd3fb2956348a08" ns2:_="" ns3:_="">
     <xsd:import namespace="77fde15d-2397-485e-b73a-86b486d76ed9"/>
@@ -28872,16 +28876,12 @@
 </ct:contentTypeSchema>
 </file>
 
+<file path=customXml/item13.xml><?xml version="1.0" encoding="utf-8"?>
+<TemplafySlideTemplateConfiguration><![CDATA[{"documentContentValidatorConfiguration":{"enableDocumentContentValidator":false,"documentContentValidatorVersion":0},"elementsMetadata":[],"slideId":"637661701761217959","enableDocumentContentUpdater":true,"version":"1.9"}]]></TemplafySlideTemplateConfiguration>
+</file>
+
 <file path=customXml/item14.xml><?xml version="1.0" encoding="utf-8"?>
-<p:properties xmlns:p="http://schemas.microsoft.com/office/2006/metadata/properties" xmlns:xsi="http://www.w3.org/2001/XMLSchema-instance" xmlns:pc="http://schemas.microsoft.com/office/infopath/2007/PartnerControls">
-  <documentManagement>
-    <TaxCatchAll xmlns="bcef248d-09fe-4034-af42-7800fb0b4c07" xsi:nil="true"/>
-    <lcf76f155ced4ddcb4097134ff3c332f xmlns="77fde15d-2397-485e-b73a-86b486d76ed9">
-      <Terms xmlns="http://schemas.microsoft.com/office/infopath/2007/PartnerControls"/>
-    </lcf76f155ced4ddcb4097134ff3c332f>
-    <_Flow_SignoffStatus xmlns="77fde15d-2397-485e-b73a-86b486d76ed9" xsi:nil="true"/>
-  </documentManagement>
-</p:properties>
+<TemplafySlideFormConfiguration><![CDATA[{"formFields":[],"formDataEntries":[]}]]></TemplafySlideFormConfiguration>
 </file>
 
 <file path=customXml/item15.xml><?xml version="1.0" encoding="utf-8"?>
@@ -28889,7 +28889,7 @@
 </file>
 
 <file path=customXml/item16.xml><?xml version="1.0" encoding="utf-8"?>
-<TemplafySlideTemplateConfiguration><![CDATA[{"documentContentValidatorConfiguration":{"enableDocumentContentValidator":false,"documentContentValidatorVersion":0},"elementsMetadata":[],"slideId":"637661701761217959","enableDocumentContentUpdater":true,"version":"1.9"}]]></TemplafySlideTemplateConfiguration>
+<TemplafySlideFormConfiguration><![CDATA[{"formFields":[],"formDataEntries":[]}]]></TemplafySlideFormConfiguration>
 </file>
 
 <file path=customXml/item17.xml><?xml version="1.0" encoding="utf-8"?>
@@ -28901,7 +28901,7 @@
 </file>
 
 <file path=customXml/item19.xml><?xml version="1.0" encoding="utf-8"?>
-<TemplafySlideFormConfiguration><![CDATA[{"formFields":[],"formDataEntries":[]}]]></TemplafySlideFormConfiguration>
+<TemplafySlideTemplateConfiguration><![CDATA[{"documentContentValidatorConfiguration":{"enableDocumentContentValidator":false,"documentContentValidatorVersion":0},"elementsMetadata":[],"slideId":"637661701761217959","enableDocumentContentUpdater":true,"version":"1.9"}]]></TemplafySlideTemplateConfiguration>
 </file>
 
 <file path=customXml/item2.xml><?xml version="1.0" encoding="utf-8"?>
@@ -28909,20 +28909,20 @@
 </file>
 
 <file path=customXml/item3.xml><?xml version="1.0" encoding="utf-8"?>
-<TemplafySlideFormConfiguration><![CDATA[{"formFields":[],"formDataEntries":[]}]]></TemplafySlideFormConfiguration>
+<TemplafySlideTemplateConfiguration><![CDATA[{"documentContentValidatorConfiguration":{"enableDocumentContentValidator":false,"documentContentValidatorVersion":0},"elementsMetadata":[],"slideId":"637661701761217959","enableDocumentContentUpdater":true,"version":"1.9"}]]></TemplafySlideTemplateConfiguration>
 </file>
 
 <file path=customXml/item4.xml><?xml version="1.0" encoding="utf-8"?>
-<TemplafySlideFormConfiguration><![CDATA[{"formFields":[],"formDataEntries":[]}]]></TemplafySlideFormConfiguration>
-</file>
-
-<file path=customXml/item5.xml><?xml version="1.0" encoding="utf-8"?>
 <?mso-contentType ?>
 <FormTemplates xmlns="http://schemas.microsoft.com/sharepoint/v3/contenttype/forms">
   <Display>DocumentLibraryForm</Display>
   <Edit>DocumentLibraryForm</Edit>
   <New>DocumentLibraryForm</New>
 </FormTemplates>
+</file>
+
+<file path=customXml/item5.xml><?xml version="1.0" encoding="utf-8"?>
+<TemplafySlideFormConfiguration><![CDATA[{"formFields":[],"formDataEntries":[]}]]></TemplafySlideFormConfiguration>
 </file>
 
 <file path=customXml/item6.xml><?xml version="1.0" encoding="utf-8"?>
@@ -28948,24 +28948,29 @@
 </file>
 
 <file path=customXml/itemProps10.xml><?xml version="1.0" encoding="utf-8"?>
-<ds:datastoreItem xmlns:ds="http://schemas.openxmlformats.org/officeDocument/2006/customXml" ds:itemID="{7FC3D2F9-C978-4F6C-9B95-BEE6303453CA}">
-  <ds:schemaRefs/>
+<ds:datastoreItem xmlns:ds="http://schemas.openxmlformats.org/officeDocument/2006/customXml" ds:itemID="{11300D8C-1DE0-4C9A-86BB-17269E5D3C65}">
+  <ds:schemaRefs>
+    <ds:schemaRef ds:uri="http://www.w3.org/XML/1998/namespace"/>
+    <ds:schemaRef ds:uri="http://purl.org/dc/elements/1.1/"/>
+    <ds:schemaRef ds:uri="http://schemas.microsoft.com/office/2006/documentManagement/types"/>
+    <ds:schemaRef ds:uri="http://schemas.microsoft.com/office/infopath/2007/PartnerControls"/>
+    <ds:schemaRef ds:uri="http://purl.org/dc/dcmitype/"/>
+    <ds:schemaRef ds:uri="http://purl.org/dc/terms/"/>
+    <ds:schemaRef ds:uri="bcef248d-09fe-4034-af42-7800fb0b4c07"/>
+    <ds:schemaRef ds:uri="http://schemas.openxmlformats.org/package/2006/metadata/core-properties"/>
+    <ds:schemaRef ds:uri="77fde15d-2397-485e-b73a-86b486d76ed9"/>
+    <ds:schemaRef ds:uri="http://schemas.microsoft.com/office/2006/metadata/properties"/>
+  </ds:schemaRefs>
 </ds:datastoreItem>
 </file>
 
 <file path=customXml/itemProps11.xml><?xml version="1.0" encoding="utf-8"?>
-<ds:datastoreItem xmlns:ds="http://schemas.openxmlformats.org/officeDocument/2006/customXml" ds:itemID="{3E86842F-01DA-4AAB-AA56-9F0B2F496397}">
+<ds:datastoreItem xmlns:ds="http://schemas.openxmlformats.org/officeDocument/2006/customXml" ds:itemID="{F1A1DCA2-547F-4B90-BE36-91B9AB619C93}">
   <ds:schemaRefs/>
 </ds:datastoreItem>
 </file>
 
 <file path=customXml/itemProps12.xml><?xml version="1.0" encoding="utf-8"?>
-<ds:datastoreItem xmlns:ds="http://schemas.openxmlformats.org/officeDocument/2006/customXml" ds:itemID="{6AE2E849-5528-4C05-B1E8-DB80DA8BD7F1}">
-  <ds:schemaRefs/>
-</ds:datastoreItem>
-</file>
-
-<file path=customXml/itemProps13.xml><?xml version="1.0" encoding="utf-8"?>
 <ds:datastoreItem xmlns:ds="http://schemas.openxmlformats.org/officeDocument/2006/customXml" ds:itemID="{7DEDA2BC-8275-4FBB-A28A-68D801E06E75}">
   <ds:schemaRefs>
     <ds:schemaRef ds:uri="http://schemas.microsoft.com/office/2006/metadata/contentType"/>
@@ -28984,31 +28989,26 @@
 </ds:datastoreItem>
 </file>
 
+<file path=customXml/itemProps13.xml><?xml version="1.0" encoding="utf-8"?>
+<ds:datastoreItem xmlns:ds="http://schemas.openxmlformats.org/officeDocument/2006/customXml" ds:itemID="{62D5B54B-6902-4F98-B23A-0118DB9EEDF4}">
+  <ds:schemaRefs/>
+</ds:datastoreItem>
+</file>
+
 <file path=customXml/itemProps14.xml><?xml version="1.0" encoding="utf-8"?>
-<ds:datastoreItem xmlns:ds="http://schemas.openxmlformats.org/officeDocument/2006/customXml" ds:itemID="{11300D8C-1DE0-4C9A-86BB-17269E5D3C65}">
-  <ds:schemaRefs>
-    <ds:schemaRef ds:uri="http://www.w3.org/XML/1998/namespace"/>
-    <ds:schemaRef ds:uri="http://purl.org/dc/elements/1.1/"/>
-    <ds:schemaRef ds:uri="http://schemas.microsoft.com/office/2006/documentManagement/types"/>
-    <ds:schemaRef ds:uri="http://schemas.microsoft.com/office/infopath/2007/PartnerControls"/>
-    <ds:schemaRef ds:uri="http://purl.org/dc/dcmitype/"/>
-    <ds:schemaRef ds:uri="http://purl.org/dc/terms/"/>
-    <ds:schemaRef ds:uri="bcef248d-09fe-4034-af42-7800fb0b4c07"/>
-    <ds:schemaRef ds:uri="http://schemas.openxmlformats.org/package/2006/metadata/core-properties"/>
-    <ds:schemaRef ds:uri="77fde15d-2397-485e-b73a-86b486d76ed9"/>
-    <ds:schemaRef ds:uri="http://schemas.microsoft.com/office/2006/metadata/properties"/>
-  </ds:schemaRefs>
+<ds:datastoreItem xmlns:ds="http://schemas.openxmlformats.org/officeDocument/2006/customXml" ds:itemID="{0B924887-3FAA-4B8E-815F-481860E4E6AF}">
+  <ds:schemaRefs/>
 </ds:datastoreItem>
 </file>
 
 <file path=customXml/itemProps15.xml><?xml version="1.0" encoding="utf-8"?>
-<ds:datastoreItem xmlns:ds="http://schemas.openxmlformats.org/officeDocument/2006/customXml" ds:itemID="{2A25ECD3-EA6C-4727-8DF2-5BDC9911D24C}">
+<ds:datastoreItem xmlns:ds="http://schemas.openxmlformats.org/officeDocument/2006/customXml" ds:itemID="{D81E0773-B1DF-4187-B86B-A4CC89F4FFA3}">
   <ds:schemaRefs/>
 </ds:datastoreItem>
 </file>
 
 <file path=customXml/itemProps16.xml><?xml version="1.0" encoding="utf-8"?>
-<ds:datastoreItem xmlns:ds="http://schemas.openxmlformats.org/officeDocument/2006/customXml" ds:itemID="{2E5DC17B-7CA5-47FA-BB10-51D0544A8F91}">
+<ds:datastoreItem xmlns:ds="http://schemas.openxmlformats.org/officeDocument/2006/customXml" ds:itemID="{6AE2E849-5528-4C05-B1E8-DB80DA8BD7F1}">
   <ds:schemaRefs/>
 </ds:datastoreItem>
 </file>
@@ -29020,36 +29020,30 @@
 </file>
 
 <file path=customXml/itemProps18.xml><?xml version="1.0" encoding="utf-8"?>
-<ds:datastoreItem xmlns:ds="http://schemas.openxmlformats.org/officeDocument/2006/customXml" ds:itemID="{62D5B54B-6902-4F98-B23A-0118DB9EEDF4}">
+<ds:datastoreItem xmlns:ds="http://schemas.openxmlformats.org/officeDocument/2006/customXml" ds:itemID="{772ABA4E-1FA2-4FC1-9A8A-C2C33BEC7DBE}">
   <ds:schemaRefs/>
 </ds:datastoreItem>
 </file>
 
 <file path=customXml/itemProps19.xml><?xml version="1.0" encoding="utf-8"?>
-<ds:datastoreItem xmlns:ds="http://schemas.openxmlformats.org/officeDocument/2006/customXml" ds:itemID="{A87FB1B0-D223-4CF6-8EC4-E3E816F1CDBE}">
+<ds:datastoreItem xmlns:ds="http://schemas.openxmlformats.org/officeDocument/2006/customXml" ds:itemID="{2E5DC17B-7CA5-47FA-BB10-51D0544A8F91}">
   <ds:schemaRefs/>
 </ds:datastoreItem>
 </file>
 
 <file path=customXml/itemProps2.xml><?xml version="1.0" encoding="utf-8"?>
-<ds:datastoreItem xmlns:ds="http://schemas.openxmlformats.org/officeDocument/2006/customXml" ds:itemID="{772ABA4E-1FA2-4FC1-9A8A-C2C33BEC7DBE}">
+<ds:datastoreItem xmlns:ds="http://schemas.openxmlformats.org/officeDocument/2006/customXml" ds:itemID="{D6A0B861-D97F-43C8-B3DF-13EB4CD7C21A}">
   <ds:schemaRefs/>
 </ds:datastoreItem>
 </file>
 
 <file path=customXml/itemProps3.xml><?xml version="1.0" encoding="utf-8"?>
-<ds:datastoreItem xmlns:ds="http://schemas.openxmlformats.org/officeDocument/2006/customXml" ds:itemID="{0B924887-3FAA-4B8E-815F-481860E4E6AF}">
+<ds:datastoreItem xmlns:ds="http://schemas.openxmlformats.org/officeDocument/2006/customXml" ds:itemID="{3E86842F-01DA-4AAB-AA56-9F0B2F496397}">
   <ds:schemaRefs/>
 </ds:datastoreItem>
 </file>
 
 <file path=customXml/itemProps4.xml><?xml version="1.0" encoding="utf-8"?>
-<ds:datastoreItem xmlns:ds="http://schemas.openxmlformats.org/officeDocument/2006/customXml" ds:itemID="{BA1C3E13-54CF-4EC8-BFFC-847950BB2BA6}">
-  <ds:schemaRefs/>
-</ds:datastoreItem>
-</file>
-
-<file path=customXml/itemProps5.xml><?xml version="1.0" encoding="utf-8"?>
 <ds:datastoreItem xmlns:ds="http://schemas.openxmlformats.org/officeDocument/2006/customXml" ds:itemID="{852C017A-4C71-4057-8850-0D69BC43C2C6}">
   <ds:schemaRefs>
     <ds:schemaRef ds:uri="http://schemas.microsoft.com/sharepoint/v3/contenttype/forms"/>
@@ -29057,20 +29051,26 @@
 </ds:datastoreItem>
 </file>
 
+<file path=customXml/itemProps5.xml><?xml version="1.0" encoding="utf-8"?>
+<ds:datastoreItem xmlns:ds="http://schemas.openxmlformats.org/officeDocument/2006/customXml" ds:itemID="{2A25ECD3-EA6C-4727-8DF2-5BDC9911D24C}">
+  <ds:schemaRefs/>
+</ds:datastoreItem>
+</file>
+
 <file path=customXml/itemProps6.xml><?xml version="1.0" encoding="utf-8"?>
-<ds:datastoreItem xmlns:ds="http://schemas.openxmlformats.org/officeDocument/2006/customXml" ds:itemID="{D6A0B861-D97F-43C8-B3DF-13EB4CD7C21A}">
+<ds:datastoreItem xmlns:ds="http://schemas.openxmlformats.org/officeDocument/2006/customXml" ds:itemID="{7FC3D2F9-C978-4F6C-9B95-BEE6303453CA}">
   <ds:schemaRefs/>
 </ds:datastoreItem>
 </file>
 
 <file path=customXml/itemProps7.xml><?xml version="1.0" encoding="utf-8"?>
-<ds:datastoreItem xmlns:ds="http://schemas.openxmlformats.org/officeDocument/2006/customXml" ds:itemID="{D81E0773-B1DF-4187-B86B-A4CC89F4FFA3}">
+<ds:datastoreItem xmlns:ds="http://schemas.openxmlformats.org/officeDocument/2006/customXml" ds:itemID="{A87FB1B0-D223-4CF6-8EC4-E3E816F1CDBE}">
   <ds:schemaRefs/>
 </ds:datastoreItem>
 </file>
 
 <file path=customXml/itemProps8.xml><?xml version="1.0" encoding="utf-8"?>
-<ds:datastoreItem xmlns:ds="http://schemas.openxmlformats.org/officeDocument/2006/customXml" ds:itemID="{F1A1DCA2-547F-4B90-BE36-91B9AB619C93}">
+<ds:datastoreItem xmlns:ds="http://schemas.openxmlformats.org/officeDocument/2006/customXml" ds:itemID="{BA1C3E13-54CF-4EC8-BFFC-847950BB2BA6}">
   <ds:schemaRefs/>
 </ds:datastoreItem>
 </file>

</xml_diff>